<commit_message>
Rework deck to business-facing + add credit-officer risk-scoring web app
- Rewrite slides (7): why the data is predictive, high-level preprocessing
  & ML workflow, the risk score, and the AI-assisted underwriting flow;
  deliberately no specific algorithms/tools named.
- Add credit_risk_app/index.html: self-contained web tool where a loan
  officer enters applicant data and gets an AI risk score, tier, default
  probability, top risk factors, and a recommendation.
- Regenerate pptx/batch_update.json; update README.

Co-Authored-By: Claude Opus 4.8 <noreply@anthropic.com>
Claude-Session: https://claude.ai/code/session_01JMJBZ1Vb1kMGFMXV1N9F17
</commit_message>
<xml_diff>
--- a/home-credit-slides/home_credit_slides.pptx
+++ b/home-credit-slides/home_credit_slides.pptx
@@ -12,12 +12,6 @@
     <p:sldId id="260" r:id="rId11"/>
     <p:sldId id="261" r:id="rId12"/>
     <p:sldId id="262" r:id="rId13"/>
-    <p:sldId id="263" r:id="rId14"/>
-    <p:sldId id="264" r:id="rId15"/>
-    <p:sldId id="265" r:id="rId16"/>
-    <p:sldId id="266" r:id="rId17"/>
-    <p:sldId id="267" r:id="rId18"/>
-    <p:sldId id="268" r:id="rId19"/>
   </p:sldIdLst>
   <p:sldSz cx="9144000" cy="6858000" type="screen4x3"/>
   <p:notesSz cx="6858000" cy="9144000"/>
@@ -3116,7 +3110,7 @@
           <a:lstStyle/>
           <a:p>
             <a:r>
-              <a:t>Home Credit 信用違約風險</a:t>
+              <a:t>信用風險評估 — AI 輔助授信</a:t>
             </a:r>
           </a:p>
         </p:txBody>
@@ -3137,376 +3131,12 @@
           <a:lstStyle/>
           <a:p>
             <a:r>
-              <a:t>Kaggle 信用評估競賽資料介紹、專案可行性、資料處理與演算法評估</a:t>
-            </a:r>
-          </a:p>
-          <a:p>
-            <a:r>
-              <a:t>（資料來源：Home Credit 2024 特徵字典 + 訓練流程規格書）</a:t>
-            </a:r>
-          </a:p>
-        </p:txBody>
-      </p:sp>
-    </p:spTree>
-  </p:cSld>
-  <p:clrMapOvr>
-    <a:masterClrMapping/>
-  </p:clrMapOvr>
-</p:sld>
-</file>
-
-<file path=ppt/slides/slide10.xml><?xml version="1.0" encoding="utf-8"?>
-<p:sld xmlns:a="http://schemas.openxmlformats.org/drawingml/2006/main" xmlns:p="http://schemas.openxmlformats.org/presentationml/2006/main" xmlns:r="http://schemas.openxmlformats.org/officeDocument/2006/relationships">
-  <p:cSld>
-    <p:spTree>
-      <p:nvGrpSpPr>
-        <p:cNvPr id="1" name=""/>
-        <p:cNvGrpSpPr/>
-        <p:nvPr/>
-      </p:nvGrpSpPr>
-      <p:grpSpPr/>
-      <p:sp>
-        <p:nvSpPr>
-          <p:cNvPr id="2" name="Title 1"/>
-          <p:cNvSpPr>
-            <a:spLocks noGrp="1"/>
-          </p:cNvSpPr>
-          <p:nvPr>
-            <p:ph type="title"/>
-          </p:nvPr>
-        </p:nvSpPr>
-        <p:spPr/>
-        <p:txBody>
-          <a:bodyPr/>
-          <a:lstStyle/>
-          <a:p>
-            <a:r>
-              <a:t>演算法選擇</a:t>
-            </a:r>
-          </a:p>
-        </p:txBody>
-      </p:sp>
-      <p:sp>
-        <p:nvSpPr>
-          <p:cNvPr id="3" name="Content Placeholder 2"/>
-          <p:cNvSpPr>
-            <a:spLocks noGrp="1"/>
-          </p:cNvSpPr>
-          <p:nvPr>
-            <p:ph idx="1"/>
-          </p:nvPr>
-        </p:nvSpPr>
-        <p:spPr/>
-        <p:txBody>
-          <a:bodyPr/>
-          <a:lstStyle/>
-          <a:p>
-            <a:pPr>
-              <a:defRPr sz="1600"/>
-            </a:pPr>
-            <a:r>
-              <a:t>基準：Logistic Regression（標準化 + L2），建立可解釋下限。</a:t>
-            </a:r>
-          </a:p>
-          <a:p>
-            <a:pPr>
-              <a:defRPr sz="1600"/>
-            </a:pPr>
-            <a:r>
-              <a:t>主力：LightGBM（梯度提升樹），原生支援缺失值與類別、訓練快、特徵多時表現佳。</a:t>
-            </a:r>
-          </a:p>
-          <a:p>
-            <a:pPr>
-              <a:defRPr sz="1600"/>
-            </a:pPr>
-            <a:r>
-              <a:t>備援：XGBoost、CatBoost（類別特徵強）；可做模型集成。</a:t>
-            </a:r>
-          </a:p>
-          <a:p>
-            <a:pPr>
-              <a:defRPr sz="1600"/>
-            </a:pPr>
-            <a:r>
-              <a:t>不平衡處理：scale_pos_weight 或 is_unbalance；以 AUC 早停。</a:t>
-            </a:r>
-          </a:p>
-          <a:p>
-            <a:pPr>
-              <a:defRPr sz="1600"/>
-            </a:pPr>
-            <a:r>
-              <a:t>穩定度導向：較強正則化(reg_alpha/lambda)、限制樹深、特徵/樣本抽樣，換取跨時間穩健。</a:t>
-            </a:r>
-          </a:p>
-        </p:txBody>
-      </p:sp>
-    </p:spTree>
-  </p:cSld>
-  <p:clrMapOvr>
-    <a:masterClrMapping/>
-  </p:clrMapOvr>
-</p:sld>
-</file>
-
-<file path=ppt/slides/slide11.xml><?xml version="1.0" encoding="utf-8"?>
-<p:sld xmlns:a="http://schemas.openxmlformats.org/drawingml/2006/main" xmlns:p="http://schemas.openxmlformats.org/presentationml/2006/main" xmlns:r="http://schemas.openxmlformats.org/officeDocument/2006/relationships">
-  <p:cSld>
-    <p:spTree>
-      <p:nvGrpSpPr>
-        <p:cNvPr id="1" name=""/>
-        <p:cNvGrpSpPr/>
-        <p:nvPr/>
-      </p:nvGrpSpPr>
-      <p:grpSpPr/>
-      <p:sp>
-        <p:nvSpPr>
-          <p:cNvPr id="2" name="Title 1"/>
-          <p:cNvSpPr>
-            <a:spLocks noGrp="1"/>
-          </p:cNvSpPr>
-          <p:nvPr>
-            <p:ph type="title"/>
-          </p:nvPr>
-        </p:nvSpPr>
-        <p:spPr/>
-        <p:txBody>
-          <a:bodyPr/>
-          <a:lstStyle/>
-          <a:p>
-            <a:r>
-              <a:t>驗證策略與超參數調整</a:t>
-            </a:r>
-          </a:p>
-        </p:txBody>
-      </p:sp>
-      <p:sp>
-        <p:nvSpPr>
-          <p:cNvPr id="3" name="Content Placeholder 2"/>
-          <p:cNvSpPr>
-            <a:spLocks noGrp="1"/>
-          </p:cNvSpPr>
-          <p:nvPr>
-            <p:ph idx="1"/>
-          </p:nvPr>
-        </p:nvSpPr>
-        <p:spPr/>
-        <p:txBody>
-          <a:bodyPr/>
-          <a:lstStyle/>
-          <a:p>
-            <a:pPr>
-              <a:defRPr sz="1600"/>
-            </a:pPr>
-            <a:r>
-              <a:t>驗證：依 WEEK_NUM 做時間感知切分 / StratifiedGroupKFold，模擬未來週次、貼近 stability 評分。</a:t>
-            </a:r>
-          </a:p>
-          <a:p>
-            <a:pPr>
-              <a:defRPr sz="1600"/>
-            </a:pPr>
-            <a:r>
-              <a:t>另留 holdout（最後一段時間）做最終驗證。</a:t>
-            </a:r>
-          </a:p>
-          <a:p>
-            <a:pPr>
-              <a:defRPr sz="1600"/>
-            </a:pPr>
-            <a:r>
-              <a:t>調參工具：Optuna（貝氏搜尋），目標為交叉驗證平均 gini/AUC。</a:t>
-            </a:r>
-          </a:p>
-          <a:p>
-            <a:pPr>
-              <a:defRPr sz="1600"/>
-            </a:pPr>
-            <a:r>
-              <a:t>LightGBM 主要參數：num_leaves、max_depth、learning_rate、min_child_samples、feature_fraction、bagging_fraction、reg_alpha、reg_lambda。</a:t>
-            </a:r>
-          </a:p>
-          <a:p>
-            <a:pPr>
-              <a:defRPr sz="1600"/>
-            </a:pPr>
-            <a:r>
-              <a:t>以 5-fold 平均分數與標準差評估穩定性。</a:t>
-            </a:r>
-          </a:p>
-        </p:txBody>
-      </p:sp>
-    </p:spTree>
-  </p:cSld>
-  <p:clrMapOvr>
-    <a:masterClrMapping/>
-  </p:clrMapOvr>
-</p:sld>
-</file>
-
-<file path=ppt/slides/slide12.xml><?xml version="1.0" encoding="utf-8"?>
-<p:sld xmlns:a="http://schemas.openxmlformats.org/drawingml/2006/main" xmlns:p="http://schemas.openxmlformats.org/presentationml/2006/main" xmlns:r="http://schemas.openxmlformats.org/officeDocument/2006/relationships">
-  <p:cSld>
-    <p:spTree>
-      <p:nvGrpSpPr>
-        <p:cNvPr id="1" name=""/>
-        <p:cNvGrpSpPr/>
-        <p:nvPr/>
-      </p:nvGrpSpPr>
-      <p:grpSpPr/>
-      <p:sp>
-        <p:nvSpPr>
-          <p:cNvPr id="2" name="Title 1"/>
-          <p:cNvSpPr>
-            <a:spLocks noGrp="1"/>
-          </p:cNvSpPr>
-          <p:nvPr>
-            <p:ph type="title"/>
-          </p:nvPr>
-        </p:nvSpPr>
-        <p:spPr/>
-        <p:txBody>
-          <a:bodyPr/>
-          <a:lstStyle/>
-          <a:p>
-            <a:r>
-              <a:t>預期成果與驗收標準</a:t>
-            </a:r>
-          </a:p>
-        </p:txBody>
-      </p:sp>
-      <p:sp>
-        <p:nvSpPr>
-          <p:cNvPr id="3" name="Content Placeholder 2"/>
-          <p:cNvSpPr>
-            <a:spLocks noGrp="1"/>
-          </p:cNvSpPr>
-          <p:nvPr>
-            <p:ph idx="1"/>
-          </p:nvPr>
-        </p:nvSpPr>
-        <p:spPr/>
-        <p:txBody>
-          <a:bodyPr/>
-          <a:lstStyle/>
-          <a:p>
-            <a:pPr>
-              <a:defRPr sz="1600"/>
-            </a:pPr>
-            <a:r>
-              <a:t>Pipeline 可從原始檔一鍵執行至產出 submission（case_id, score）。</a:t>
-            </a:r>
-          </a:p>
-          <a:p>
-            <a:pPr>
-              <a:defRPr sz="1600"/>
-            </a:pPr>
-            <a:r>
-              <a:t>LightGBM baseline 交叉驗證 AUC 目標 ≥ 0.78（規格書門檻）；持續優化 gini 穩定度。</a:t>
-            </a:r>
-          </a:p>
-          <a:p>
-            <a:pPr>
-              <a:defRPr sz="1600"/>
-            </a:pPr>
-            <a:r>
-              <a:t>輸出特徵重要性 / SHAP 報告，提供業務可理解的風險因子。</a:t>
-            </a:r>
-          </a:p>
-          <a:p>
-            <a:pPr>
-              <a:defRPr sz="1600"/>
-            </a:pPr>
-            <a:r>
-              <a:t>全流程可重現（固定 seed）、模型序列化保存，支援對測試集推論。</a:t>
-            </a:r>
-          </a:p>
-        </p:txBody>
-      </p:sp>
-    </p:spTree>
-  </p:cSld>
-  <p:clrMapOvr>
-    <a:masterClrMapping/>
-  </p:clrMapOvr>
-</p:sld>
-</file>
-
-<file path=ppt/slides/slide13.xml><?xml version="1.0" encoding="utf-8"?>
-<p:sld xmlns:a="http://schemas.openxmlformats.org/drawingml/2006/main" xmlns:p="http://schemas.openxmlformats.org/presentationml/2006/main" xmlns:r="http://schemas.openxmlformats.org/officeDocument/2006/relationships">
-  <p:cSld>
-    <p:spTree>
-      <p:nvGrpSpPr>
-        <p:cNvPr id="1" name=""/>
-        <p:cNvGrpSpPr/>
-        <p:nvPr/>
-      </p:nvGrpSpPr>
-      <p:grpSpPr/>
-      <p:sp>
-        <p:nvSpPr>
-          <p:cNvPr id="2" name="Title 1"/>
-          <p:cNvSpPr>
-            <a:spLocks noGrp="1"/>
-          </p:cNvSpPr>
-          <p:nvPr>
-            <p:ph type="title"/>
-          </p:nvPr>
-        </p:nvSpPr>
-        <p:spPr/>
-        <p:txBody>
-          <a:bodyPr/>
-          <a:lstStyle/>
-          <a:p>
-            <a:r>
-              <a:t>風險、下一步與結論</a:t>
-            </a:r>
-          </a:p>
-        </p:txBody>
-      </p:sp>
-      <p:sp>
-        <p:nvSpPr>
-          <p:cNvPr id="3" name="Content Placeholder 2"/>
-          <p:cNvSpPr>
-            <a:spLocks noGrp="1"/>
-          </p:cNvSpPr>
-          <p:nvPr>
-            <p:ph idx="1"/>
-          </p:nvPr>
-        </p:nvSpPr>
-        <p:spPr/>
-        <p:txBody>
-          <a:bodyPr/>
-          <a:lstStyle/>
-          <a:p>
-            <a:pPr>
-              <a:defRPr sz="1600"/>
-            </a:pPr>
-            <a:r>
-              <a:t>風險：特徵洩漏(時間因果)、近期分布漂移、過擬合單一時段。</a:t>
-            </a:r>
-          </a:p>
-          <a:p>
-            <a:pPr>
-              <a:defRPr sz="1600"/>
-            </a:pPr>
-            <a:r>
-              <a:t>下一步：先建 LightGBM baseline → 時間感知 CV → 加聚合特徵 → Optuna 調參 → 監控穩定度。</a:t>
-            </a:r>
-          </a:p>
-          <a:p>
-            <a:pPr>
-              <a:defRPr sz="1600"/>
-            </a:pPr>
-            <a:r>
-              <a:t>工程：以 Polars/DuckDB 控管資料量；Pipeline 模組化（loader/cleaning/fe/train/predict）。</a:t>
-            </a:r>
-          </a:p>
-          <a:p>
-            <a:pPr>
-              <a:defRPr sz="1600"/>
-            </a:pPr>
-            <a:r>
-              <a:t>結論：資料完備、技術成熟、資源可控，專案高度可行，建議以穩定度為核心目標推進。</a:t>
+              <a:t>從來源資料到風險分數：資料為何能預測、如何前處理與訓練，</a:t>
+            </a:r>
+          </a:p>
+          <a:p>
+            <a:r>
+              <a:t>以及授信人員的實務應用（AI 輔助、產生風險分數）</a:t>
             </a:r>
           </a:p>
         </p:txBody>
@@ -3545,7 +3175,7 @@
           <a:lstStyle/>
           <a:p>
             <a:r>
-              <a:t>競賽與資料集介紹</a:t>
+              <a:t>為什麼這些資料能預測違約風險</a:t>
             </a:r>
           </a:p>
         </p:txBody>
@@ -3569,7 +3199,7 @@
               <a:defRPr sz="1600"/>
             </a:pPr>
             <a:r>
-              <a:t>目標：依申請人資料預測貸款是否違約（target：0=正常，1=違約），協助對信用紀錄不足的族群做風險評估。</a:t>
+              <a:t>過往還款行為：逾期天數、準時繳款比例 —— 最直接反映償債意願與能力。</a:t>
             </a:r>
           </a:p>
           <a:p>
@@ -3577,7 +3207,7 @@
               <a:defRPr sz="1600"/>
             </a:pPr>
             <a:r>
-              <a:t>附件特徵字典共 465 個欄位，採 _&lt;id&gt;&lt;型別&gt; 命名（如 amount_1115A、approvaldate_319D），屬於 2024「Credit Risk Model Stability」競賽。</a:t>
+              <a:t>負債與收入結構：授信金額/收入、月攤還/收入比 —— 衡量還款壓力是否過重。</a:t>
             </a:r>
           </a:p>
           <a:p>
@@ -3585,7 +3215,7 @@
               <a:defRPr sz="1600"/>
             </a:pPr>
             <a:r>
-              <a:t>與規格書(spec.md)所述 2018 版差異：2018 以 SK_ID_CURR 為主鍵、多張 csv（bureau、previous_application…）；2024 以 case_id 為主鍵、parquet 多深度表，並新增『模型穩定度』要求。</a:t>
+              <a:t>既有信貸狀況：在各機構的貸款筆數與未償餘額 —— 反映整體負債水位。</a:t>
             </a:r>
           </a:p>
           <a:p>
@@ -3593,7 +3223,31 @@
               <a:defRPr sz="1600"/>
             </a:pPr>
             <a:r>
-              <a:t>本簡報以 2024 實際資料為準，沿用規格書的 Pipeline 架構（兩版流程高度相通）。</a:t>
+              <a:t>申請與查詢頻率：短期內多次申請 —— 常是資金緊張的警訊。</a:t>
+            </a:r>
+          </a:p>
+          <a:p>
+            <a:pPr>
+              <a:defRPr sz="1600"/>
+            </a:pPr>
+            <a:r>
+              <a:t>金流穩定度：收入與帳戶進出是否穩定 —— 代表財務健康程度。</a:t>
+            </a:r>
+          </a:p>
+          <a:p>
+            <a:pPr>
+              <a:defRPr sz="1600"/>
+            </a:pPr>
+            <a:r>
+              <a:t>申請人輪廓：年齡、年資、帳戶類型等 —— 協助區隔不同風險族群。</a:t>
+            </a:r>
+          </a:p>
+          <a:p>
+            <a:pPr>
+              <a:defRPr sz="1600"/>
+            </a:pPr>
+            <a:r>
+              <a:t>小結：這些『行為 + 結構』訊號彼此互補，足以在統計上區分高/低風險。</a:t>
             </a:r>
           </a:p>
         </p:txBody>
@@ -3632,7 +3286,7 @@
           <a:lstStyle/>
           <a:p>
             <a:r>
-              <a:t>資料結構與檔案</a:t>
+              <a:t>資料前處理與機器學習流程（總覽）</a:t>
             </a:r>
           </a:p>
         </p:txBody>
@@ -3656,7 +3310,7 @@
               <a:defRPr sz="1600"/>
             </a:pPr>
             <a:r>
-              <a:t>主表 base：case_id、date_decision、WEEK_NUM、MONTH、target，定義每筆申請與時間軸。</a:t>
+              <a:t>探索分析(EDA)：先看資料分布、缺失與異常，並注意違約屬於少數族群（不平衡）。</a:t>
             </a:r>
           </a:p>
           <a:p>
@@ -3664,7 +3318,7 @@
               <a:defRPr sz="1600"/>
             </a:pPr>
             <a:r>
-              <a:t>特徵表依 depth 分層：depth 0（單列／申請當下）、depth 1、depth 2（一對多歷史，需聚合）。</a:t>
+              <a:t>資料清理：修正異常值與日期格式、處理缺失值，讓資料一致可用。</a:t>
             </a:r>
           </a:p>
           <a:p>
@@ -3672,7 +3326,7 @@
               <a:defRPr sz="1600"/>
             </a:pPr>
             <a:r>
-              <a:t>主題涵蓋：聯徵紀錄、過往申請、稅務、存款／簽帳卡金流、分期還款、人口統計等。</a:t>
+              <a:t>特徵工程：把多筆歷史紀錄彙整成每位申請人的『行為摘要與比率指標』，並挑出最有預測力的特徵。</a:t>
             </a:r>
           </a:p>
           <a:p>
@@ -3680,7 +3334,7 @@
               <a:defRPr sz="1600"/>
             </a:pPr>
             <a:r>
-              <a:t>串接鍵：以 case_id 將各表 left join 回主表；depth 1/2 需先 groupby(case_id) 聚合為單列。</a:t>
+              <a:t>資料切分(Split)：分訓練/驗證，且依時間切分，確保模型對『未來新案件』仍然準確。</a:t>
             </a:r>
           </a:p>
           <a:p>
@@ -3688,7 +3342,15 @@
               <a:defRPr sz="1600"/>
             </a:pPr>
             <a:r>
-              <a:t>格式為 parquet、資料量達數 GB，建議用 Polars / DuckDB 做高效聚合。</a:t>
+              <a:t>模型訓練與評估：讓模型從歷史案件學習違約樣態，再用沒看過的資料檢驗可靠度與穩定度。</a:t>
+            </a:r>
+          </a:p>
+          <a:p>
+            <a:pPr>
+              <a:defRPr sz="1600"/>
+            </a:pPr>
+            <a:r>
+              <a:t>產出：為每一筆申請輸出一個『風險分數』。</a:t>
             </a:r>
           </a:p>
         </p:txBody>
@@ -3727,7 +3389,7 @@
           <a:lstStyle/>
           <a:p>
             <a:r>
-              <a:t>特徵字典概覽（465 欄位）</a:t>
+              <a:t>模型產出：風險分數的意義</a:t>
             </a:r>
           </a:p>
         </p:txBody>
@@ -3751,7 +3413,7 @@
               <a:defRPr sz="1600"/>
             </a:pPr>
             <a:r>
-              <a:t>命名後綴即資料型別線索，分布如下：</a:t>
+              <a:t>模型把眾多訊號濃縮成單一『風險分數』，便於快速判讀。</a:t>
             </a:r>
           </a:p>
           <a:p>
@@ -3759,7 +3421,7 @@
               <a:defRPr sz="1600"/>
             </a:pPr>
             <a:r>
-              <a:t>L 其他/一般轉換 187；A 金額 102；M 遮罩類別 63；D 日期 57；P 逾期天數(DPD) 33；T 其他轉換 22。</a:t>
+              <a:t>分數對應違約機率，可切分為 低 / 中 / 高 三個風險等級。</a:t>
             </a:r>
           </a:p>
           <a:p>
@@ -3767,7 +3429,7 @@
               <a:defRPr sz="1600"/>
             </a:pPr>
             <a:r>
-              <a:t>金額類(A)：授信額度、攤還金額、存款餘額、扣繳稅額等 → 適合做比率與統計聚合。</a:t>
+              <a:t>同時列出『主要風險因子』，讓判斷可解釋、可向客戶與主管說明。</a:t>
             </a:r>
           </a:p>
           <a:p>
@@ -3775,23 +3437,7 @@
               <a:defRPr sz="1600"/>
             </a:pPr>
             <a:r>
-              <a:t>日期類(D)：核准日、指派日等 → 轉為距今天數、區間長度等時間特徵。</a:t>
-            </a:r>
-          </a:p>
-          <a:p>
-            <a:pPr>
-              <a:defRPr sz="1600"/>
-            </a:pPr>
-            <a:r>
-              <a:t>逾期類(P)：avgdpd、maxdpd 等 → 違約風險最直接訊號。</a:t>
-            </a:r>
-          </a:p>
-          <a:p>
-            <a:pPr>
-              <a:defRPr sz="1600"/>
-            </a:pPr>
-            <a:r>
-              <a:t>類別類(M)：地址行政區、帳戶類型等 → 樹模型可原生處理或目標編碼。</a:t>
+              <a:t>重視穩定度：分數須隨時間維持可靠，不因近期樣態變動而失準。</a:t>
             </a:r>
           </a:p>
         </p:txBody>
@@ -3830,7 +3476,7 @@
           <a:lstStyle/>
           <a:p>
             <a:r>
-              <a:t>評估指標：Gini 穩定度</a:t>
+              <a:t>實務應用：AI 輔助授信流程</a:t>
             </a:r>
           </a:p>
         </p:txBody>
@@ -3854,7 +3500,7 @@
               <a:defRPr sz="1600"/>
             </a:pPr>
             <a:r>
-              <a:t>主指標為自訂的『gini stability』，不只看單一 AUC，而看跨時間(WEEK_NUM)的表現穩定度。</a:t>
+              <a:t>收件 → 帶入/輸入申請人資料 → AI 模型即時產生風險分數與等級。</a:t>
             </a:r>
           </a:p>
           <a:p>
@@ -3862,7 +3508,7 @@
               <a:defRPr sz="1600"/>
             </a:pPr>
             <a:r>
-              <a:t>每週計算 gini = 2×AUC − 1；對各週 gini 擬合線性迴歸取斜率 a。</a:t>
+              <a:t>低風險：快速核准；中風險：人工複審並補件；高風險：加強審查或婉拒。</a:t>
             </a:r>
           </a:p>
           <a:p>
@@ -3870,7 +3516,7 @@
               <a:defRPr sz="1600"/>
             </a:pPr>
             <a:r>
-              <a:t>穩定度 = mean(gini) + 88.0×min(0, a) − 0.5×std(殘差)：效能隨時間下滑或波動都會被重罰。</a:t>
+              <a:t>AI 是『輔助』而非取代：最終決策由授信人員結合分數、因子與經驗判斷。</a:t>
             </a:r>
           </a:p>
           <a:p>
@@ -3878,7 +3524,7 @@
               <a:defRPr sz="1600"/>
             </a:pPr>
             <a:r>
-              <a:t>啟示：模型不能只追求驗證集高分，須具時間泛化力與穩健性（正則化、特徵穩定）。</a:t>
+              <a:t>效益：加速審件、統一風險判讀標準、降低人為遺漏、保留決策軌跡。</a:t>
             </a:r>
           </a:p>
         </p:txBody>
@@ -3917,7 +3563,7 @@
           <a:lstStyle/>
           <a:p>
             <a:r>
-              <a:t>專案可行性評估</a:t>
+              <a:t>網頁設計：授信風險評估輔助工具</a:t>
             </a:r>
           </a:p>
         </p:txBody>
@@ -3941,7 +3587,7 @@
               <a:defRPr sz="1600"/>
             </a:pPr>
             <a:r>
-              <a:t>資料面：標籤明確、特徵豐富(數百~上千)、公開 baseline 與 notebook 成熟 → 高度可行。</a:t>
+              <a:t>輸入區：申請人關鍵欄位（年齡、年收入、授信金額、月攤還、年資、過往逾期、既有貸款數、外部信用分數…）。</a:t>
             </a:r>
           </a:p>
           <a:p>
@@ -3949,7 +3595,7 @@
               <a:defRPr sz="1600"/>
             </a:pPr>
             <a:r>
-              <a:t>挑戰一 類別不平衡：違約僅約 3%，須用 AUC/Gini 為主、佐以 scale_pos_weight。</a:t>
+              <a:t>一鍵『AI 風險評估』，即時計算。</a:t>
             </a:r>
           </a:p>
           <a:p>
@@ -3957,7 +3603,7 @@
               <a:defRPr sz="1600"/>
             </a:pPr>
             <a:r>
-              <a:t>挑戰二 資料規模：多表數 GB，記憶體與聚合是瓶頸 → Polars/DuckDB、分塊與型別優化。</a:t>
+              <a:t>輸出區：風險分數儀表、風險等級、預估違約機率、主要風險因子清單、建議處置。</a:t>
             </a:r>
           </a:p>
           <a:p>
@@ -3965,7 +3611,7 @@
               <a:defRPr sz="1600"/>
             </a:pPr>
             <a:r>
-              <a:t>挑戰三 穩定度要求：須做時間感知驗證，避免過擬合近期資料。</a:t>
+              <a:t>合規提示：分數為決策輔助，仍須人工複核並符合法遵要求。</a:t>
             </a:r>
           </a:p>
           <a:p>
@@ -3973,23 +3619,7 @@
               <a:defRPr sz="1600"/>
             </a:pPr>
             <a:r>
-              <a:t>資源：單機(16~32GB RAM) + LightGBM 即可達競爭力；GPU 非必要。</a:t>
-            </a:r>
-          </a:p>
-          <a:p>
-            <a:pPr>
-              <a:defRPr sz="1600"/>
-            </a:pPr>
-            <a:r>
-              <a:t>商業價值高：可解釋(SHAP) 的風險因子報告可直接支援授信決策。</a:t>
-            </a:r>
-          </a:p>
-          <a:p>
-            <a:pPr>
-              <a:defRPr sz="1600"/>
-            </a:pPr>
-            <a:r>
-              <a:t>結論：技術與資源門檻可控，建議推進，以 LightGBM 為主力先建立穩定 baseline。</a:t>
+              <a:t>（實際互動畫面見隨附網頁 credit_risk_app/index.html）</a:t>
             </a:r>
           </a:p>
         </p:txBody>
@@ -4028,7 +3658,7 @@
           <a:lstStyle/>
           <a:p>
             <a:r>
-              <a:t>資料處理流程總覽</a:t>
+              <a:t>價值與結論</a:t>
             </a:r>
           </a:p>
         </p:txBody>
@@ -4052,7 +3682,7 @@
               <a:defRPr sz="1600"/>
             </a:pPr>
             <a:r>
-              <a:t>1. 資料載入：parquet 讀取、以 case_id 對齊、型別優化。</a:t>
+              <a:t>來源資料涵蓋行為與結構訊號 —— 具備足夠的違約預測力。</a:t>
             </a:r>
           </a:p>
           <a:p>
@@ -4060,7 +3690,7 @@
               <a:defRPr sz="1600"/>
             </a:pPr>
             <a:r>
-              <a:t>2. EDA：標籤不平衡、缺失率、異常碼、欄位 cardinality 與時間分布。</a:t>
+              <a:t>標準化的前處理與訓練流程 —— 結果穩定、可重現、可解釋。</a:t>
             </a:r>
           </a:p>
           <a:p>
@@ -4068,7 +3698,7 @@
               <a:defRPr sz="1600"/>
             </a:pPr>
             <a:r>
-              <a:t>3. 資料清理：異常值轉 NaN、日期正負號修正、類別缺失處理。</a:t>
+              <a:t>落地為授信人員的網頁工具 —— 即時風險分數，授信決策更快也更一致。</a:t>
             </a:r>
           </a:p>
           <a:p>
@@ -4076,213 +3706,7 @@
               <a:defRPr sz="1600"/>
             </a:pPr>
             <a:r>
-              <a:t>4. 特徵工程：比率、時間、聚合（depth 1/2 的 mean/max/sum/std/last）。</a:t>
-            </a:r>
-          </a:p>
-          <a:p>
-            <a:pPr>
-              <a:defRPr sz="1600"/>
-            </a:pPr>
-            <a:r>
-              <a:t>5. 特徵彙整：left join 回主表、移除高缺失/零變異/高共線特徵。</a:t>
-            </a:r>
-          </a:p>
-          <a:p>
-            <a:pPr>
-              <a:defRPr sz="1600"/>
-            </a:pPr>
-            <a:r>
-              <a:t>6. 切分→7. 訓練→8. 評估→9. 調參→10. 推論→11. 提交檔。</a:t>
-            </a:r>
-          </a:p>
-        </p:txBody>
-      </p:sp>
-    </p:spTree>
-  </p:cSld>
-  <p:clrMapOvr>
-    <a:masterClrMapping/>
-  </p:clrMapOvr>
-</p:sld>
-</file>
-
-<file path=ppt/slides/slide8.xml><?xml version="1.0" encoding="utf-8"?>
-<p:sld xmlns:a="http://schemas.openxmlformats.org/drawingml/2006/main" xmlns:p="http://schemas.openxmlformats.org/presentationml/2006/main" xmlns:r="http://schemas.openxmlformats.org/officeDocument/2006/relationships">
-  <p:cSld>
-    <p:spTree>
-      <p:nvGrpSpPr>
-        <p:cNvPr id="1" name=""/>
-        <p:cNvGrpSpPr/>
-        <p:nvPr/>
-      </p:nvGrpSpPr>
-      <p:grpSpPr/>
-      <p:sp>
-        <p:nvSpPr>
-          <p:cNvPr id="2" name="Title 1"/>
-          <p:cNvSpPr>
-            <a:spLocks noGrp="1"/>
-          </p:cNvSpPr>
-          <p:nvPr>
-            <p:ph type="title"/>
-          </p:nvPr>
-        </p:nvSpPr>
-        <p:spPr/>
-        <p:txBody>
-          <a:bodyPr/>
-          <a:lstStyle/>
-          <a:p>
-            <a:r>
-              <a:t>資料清理與異常處理</a:t>
-            </a:r>
-          </a:p>
-        </p:txBody>
-      </p:sp>
-      <p:sp>
-        <p:nvSpPr>
-          <p:cNvPr id="3" name="Content Placeholder 2"/>
-          <p:cNvSpPr>
-            <a:spLocks noGrp="1"/>
-          </p:cNvSpPr>
-          <p:nvPr>
-            <p:ph idx="1"/>
-          </p:nvPr>
-        </p:nvSpPr>
-        <p:spPr/>
-        <p:txBody>
-          <a:bodyPr/>
-          <a:lstStyle/>
-          <a:p>
-            <a:pPr>
-              <a:defRPr sz="1600"/>
-            </a:pPr>
-            <a:r>
-              <a:t>異常碼：將哨兵值（如就業天數的異常極大值）統一轉為 NaN，避免污染分布。</a:t>
-            </a:r>
-          </a:p>
-          <a:p>
-            <a:pPr>
-              <a:defRPr sz="1600"/>
-            </a:pPr>
-            <a:r>
-              <a:t>日期欄(_D)：多為相對天數，統一符號並轉為正向『距今天數』。</a:t>
-            </a:r>
-          </a:p>
-          <a:p>
-            <a:pPr>
-              <a:defRPr sz="1600"/>
-            </a:pPr>
-            <a:r>
-              <a:t>類別欄(_M)：缺失補 'Unknown' 或保留交由 LightGBM/CatBoost 原生處理。</a:t>
-            </a:r>
-          </a:p>
-          <a:p>
-            <a:pPr>
-              <a:defRPr sz="1600"/>
-            </a:pPr>
-            <a:r>
-              <a:t>高缺失(&gt;80%) 與零變異欄位移除；高度共線(|r|&gt;0.95) 擇一保留。</a:t>
-            </a:r>
-          </a:p>
-          <a:p>
-            <a:pPr>
-              <a:defRPr sz="1600"/>
-            </a:pPr>
-            <a:r>
-              <a:t>全程固定 random seed，確保可重現性。</a:t>
-            </a:r>
-          </a:p>
-        </p:txBody>
-      </p:sp>
-    </p:spTree>
-  </p:cSld>
-  <p:clrMapOvr>
-    <a:masterClrMapping/>
-  </p:clrMapOvr>
-</p:sld>
-</file>
-
-<file path=ppt/slides/slide9.xml><?xml version="1.0" encoding="utf-8"?>
-<p:sld xmlns:a="http://schemas.openxmlformats.org/drawingml/2006/main" xmlns:p="http://schemas.openxmlformats.org/presentationml/2006/main" xmlns:r="http://schemas.openxmlformats.org/officeDocument/2006/relationships">
-  <p:cSld>
-    <p:spTree>
-      <p:nvGrpSpPr>
-        <p:cNvPr id="1" name=""/>
-        <p:cNvGrpSpPr/>
-        <p:nvPr/>
-      </p:nvGrpSpPr>
-      <p:grpSpPr/>
-      <p:sp>
-        <p:nvSpPr>
-          <p:cNvPr id="2" name="Title 1"/>
-          <p:cNvSpPr>
-            <a:spLocks noGrp="1"/>
-          </p:cNvSpPr>
-          <p:nvPr>
-            <p:ph type="title"/>
-          </p:nvPr>
-        </p:nvSpPr>
-        <p:spPr/>
-        <p:txBody>
-          <a:bodyPr/>
-          <a:lstStyle/>
-          <a:p>
-            <a:r>
-              <a:t>特徵工程與多表彙整</a:t>
-            </a:r>
-          </a:p>
-        </p:txBody>
-      </p:sp>
-      <p:sp>
-        <p:nvSpPr>
-          <p:cNvPr id="3" name="Content Placeholder 2"/>
-          <p:cNvSpPr>
-            <a:spLocks noGrp="1"/>
-          </p:cNvSpPr>
-          <p:nvPr>
-            <p:ph idx="1"/>
-          </p:nvPr>
-        </p:nvSpPr>
-        <p:spPr/>
-        <p:txBody>
-          <a:bodyPr/>
-          <a:lstStyle/>
-          <a:p>
-            <a:pPr>
-              <a:defRPr sz="1600"/>
-            </a:pPr>
-            <a:r>
-              <a:t>比率特徵：授信/收入、攤還/收入、負債/額度等風險敏感比值。</a:t>
-            </a:r>
-          </a:p>
-          <a:p>
-            <a:pPr>
-              <a:defRPr sz="1600"/>
-            </a:pPr>
-            <a:r>
-              <a:t>時間特徵：年齡、年資、合約存續期間、最近一次逾期距今天數。</a:t>
-            </a:r>
-          </a:p>
-          <a:p>
-            <a:pPr>
-              <a:defRPr sz="1600"/>
-            </a:pPr>
-            <a:r>
-              <a:t>歷史聚合（依 case_id groupby）：逾期天數的 mean/max/std、繳款準時率、未償餘額統計、申請/核准次數。</a:t>
-            </a:r>
-          </a:p>
-          <a:p>
-            <a:pPr>
-              <a:defRPr sz="1600"/>
-            </a:pPr>
-            <a:r>
-              <a:t>depth 2 → depth 1 → base 逐層聚合，控制特徵爆炸與記憶體。</a:t>
-            </a:r>
-          </a:p>
-          <a:p>
-            <a:pPr>
-              <a:defRPr sz="1600"/>
-            </a:pPr>
-            <a:r>
-              <a:t>類別編碼：樹模型用 Label/原生處理；必要時用平滑後的目標編碼(避免洩漏)。</a:t>
+              <a:t>AI 定位為輔助決策，兼顧效率、風險控管與可解釋性。</a:t>
             </a:r>
           </a:p>
         </p:txBody>

</xml_diff>

<commit_message>
Cite Home Credit Default Risk Kaggle dataset; revise why-predictive slide
- Add explicit data-source attribution to the Kaggle 'Home Credit
  Default Risk' competition on the title slide and the 'why the data is
  predictive' slide.
- Reframe the why-predictive slide around learning from historical
  applicant records + the default outcome (TARGET) label.
- Regenerate pptx/batch_update.json; note source in README.

Co-Authored-By: Claude Opus 4.8 <noreply@anthropic.com>
Claude-Session: https://claude.ai/code/session_01JMJBZ1Vb1kMGFMXV1N9F17
</commit_message>
<xml_diff>
--- a/home-credit-slides/home_credit_slides.pptx
+++ b/home-credit-slides/home_credit_slides.pptx
@@ -3131,12 +3131,12 @@
           <a:lstStyle/>
           <a:p>
             <a:r>
-              <a:t>從來源資料到風險分數：資料為何能預測、如何前處理與訓練，</a:t>
-            </a:r>
-          </a:p>
-          <a:p>
-            <a:r>
-              <a:t>以及授信人員的實務應用（AI 輔助、產生風險分數）</a:t>
+              <a:t>資料來源：Kaggle —「Home Credit Default Risk」競賽</a:t>
+            </a:r>
+          </a:p>
+          <a:p>
+            <a:r>
+              <a:t>從來源資料到風險分數：資料為何能預測、如何前處理與訓練，以及授信人員的實務應用</a:t>
             </a:r>
           </a:p>
         </p:txBody>
@@ -3199,6 +3199,14 @@
               <a:defRPr sz="1600"/>
             </a:pPr>
             <a:r>
+              <a:t>資料來源：Kaggle「Home Credit Default Risk」競賽——以真實貸款申請人的歷史紀錄，搭配是否違約的結果(TARGET)為標籤，供模型學習。</a:t>
+            </a:r>
+          </a:p>
+          <a:p>
+            <a:pPr>
+              <a:defRPr sz="1600"/>
+            </a:pPr>
+            <a:r>
               <a:t>過往還款行為：逾期天數、準時繳款比例 —— 最直接反映償債意願與能力。</a:t>
             </a:r>
           </a:p>
@@ -3231,7 +3239,7 @@
               <a:defRPr sz="1600"/>
             </a:pPr>
             <a:r>
-              <a:t>金流穩定度：收入與帳戶進出是否穩定 —— 代表財務健康程度。</a:t>
+              <a:t>金流穩定度與申請人輪廓：收入/帳戶進出穩定度、年齡、年資等 —— 反映財務健康並區隔風險族群。</a:t>
             </a:r>
           </a:p>
           <a:p>
@@ -3239,15 +3247,7 @@
               <a:defRPr sz="1600"/>
             </a:pPr>
             <a:r>
-              <a:t>申請人輪廓：年齡、年資、帳戶類型等 —— 協助區隔不同風險族群。</a:t>
-            </a:r>
-          </a:p>
-          <a:p>
-            <a:pPr>
-              <a:defRPr sz="1600"/>
-            </a:pPr>
-            <a:r>
-              <a:t>小結：這些『行為 + 結構』訊號彼此互補，足以在統計上區分高/低風險。</a:t>
+              <a:t>小結：上述『行為 + 結構』訊號與歷史違約結果高度相關，故模型能據此在統計上區分高/低風險。</a:t>
             </a:r>
           </a:p>
         </p:txBody>

</xml_diff>

<commit_message>
Retitle deck to 2024 Credit Risk Model Stability; add 2024-vs-2018 slide
- Title/source now cite Kaggle 'Home Credit - Credit Risk Model
  Stability' (2024 version).
- New comparison slide: source data, column naming, and model goal
  (reliability/stability) vs the 2018 'Home Credit Default Risk'.
- Regenerate pptx/batch_update.json; update README source line.

Co-Authored-By: Claude Opus 4.8 <noreply@anthropic.com>
Claude-Session: https://claude.ai/code/session_01JMJBZ1Vb1kMGFMXV1N9F17
</commit_message>
<xml_diff>
--- a/home-credit-slides/home_credit_slides.pptx
+++ b/home-credit-slides/home_credit_slides.pptx
@@ -12,6 +12,7 @@
     <p:sldId id="260" r:id="rId11"/>
     <p:sldId id="261" r:id="rId12"/>
     <p:sldId id="262" r:id="rId13"/>
+    <p:sldId id="263" r:id="rId14"/>
   </p:sldIdLst>
   <p:sldSz cx="9144000" cy="6858000" type="screen4x3"/>
   <p:notesSz cx="6858000" cy="9144000"/>
@@ -3131,7 +3132,7 @@
           <a:lstStyle/>
           <a:p>
             <a:r>
-              <a:t>資料來源：Kaggle —「Home Credit Default Risk」競賽</a:t>
+              <a:t>競賽：Kaggle —「Home Credit - Credit Risk Model Stability」(2024 年版)</a:t>
             </a:r>
           </a:p>
           <a:p>
@@ -3175,7 +3176,7 @@
           <a:lstStyle/>
           <a:p>
             <a:r>
-              <a:t>為什麼這些資料能預測違約風險</a:t>
+              <a:t>競賽版本差異：2024 版 vs 2018 版</a:t>
             </a:r>
           </a:p>
         </p:txBody>
@@ -3199,7 +3200,7 @@
               <a:defRPr sz="1600"/>
             </a:pPr>
             <a:r>
-              <a:t>資料來源：Kaggle「Home Credit Default Risk」競賽——以真實貸款申請人的歷史紀錄，搭配是否違約的結果(TARGET)為標籤，供模型學習。</a:t>
+              <a:t>本專案採用版本：2024「Home Credit - Credit Risk Model Stability」；2018 舊版為「Home Credit Default Risk」。</a:t>
             </a:r>
           </a:p>
           <a:p>
@@ -3207,7 +3208,7 @@
               <a:defRPr sz="1600"/>
             </a:pPr>
             <a:r>
-              <a:t>過往還款行為：逾期天數、準時繳款比例 —— 最直接反映償債意願與能力。</a:t>
+              <a:t>來源資料：2024 採多檔分層（主表 base + 各 depth 特徵表）、主鍵 case_id、並含時間欄 WEEK_NUM；2018 以 SK_ID_CURR 為主鍵、bureau / previous_application 等多張 csv。</a:t>
             </a:r>
           </a:p>
           <a:p>
@@ -3215,7 +3216,7 @@
               <a:defRPr sz="1600"/>
             </a:pPr>
             <a:r>
-              <a:t>負債與收入結構：授信金額/收入、月攤還/收入比 —— 衡量還款壓力是否過重。</a:t>
+              <a:t>欄位：2024 欄位以『_型別』後綴匿名命名（_A 金額、_D 日期、_M 類別、_P 逾期…），共數百欄；2018 為具語意名稱（如 AMT_INCOME_TOTAL）。</a:t>
             </a:r>
           </a:p>
           <a:p>
@@ -3223,7 +3224,7 @@
               <a:defRPr sz="1600"/>
             </a:pPr>
             <a:r>
-              <a:t>既有信貸狀況：在各機構的貸款筆數與未償餘額 —— 反映整體負債水位。</a:t>
+              <a:t>模型目標（可靠度）：2024 強調『穩定度/可靠度』——不只看單次 AUC，更要求預測表現隨時間（各週）維持穩定，採自訂 gini 穩定度指標，效能下滑會被懲罰；2018 僅以 AUC-ROC 評分。</a:t>
             </a:r>
           </a:p>
           <a:p>
@@ -3231,23 +3232,7 @@
               <a:defRPr sz="1600"/>
             </a:pPr>
             <a:r>
-              <a:t>申請與查詢頻率：短期內多次申請 —— 常是資金緊張的警訊。</a:t>
-            </a:r>
-          </a:p>
-          <a:p>
-            <a:pPr>
-              <a:defRPr sz="1600"/>
-            </a:pPr>
-            <a:r>
-              <a:t>金流穩定度與申請人輪廓：收入/帳戶進出穩定度、年齡、年資等 —— 反映財務健康並區隔風險族群。</a:t>
-            </a:r>
-          </a:p>
-          <a:p>
-            <a:pPr>
-              <a:defRPr sz="1600"/>
-            </a:pPr>
-            <a:r>
-              <a:t>小結：上述『行為 + 結構』訊號與歷史違約結果高度相關，故模型能據此在統計上區分高/低風險。</a:t>
+              <a:t>意涵：2024 版更貼近實務——模型上線後須長期穩定可靠，而非只在歷史測試集上分數高。</a:t>
             </a:r>
           </a:p>
         </p:txBody>
@@ -3286,7 +3271,7 @@
           <a:lstStyle/>
           <a:p>
             <a:r>
-              <a:t>資料前處理與機器學習流程（總覽）</a:t>
+              <a:t>為什麼這些資料能預測違約風險</a:t>
             </a:r>
           </a:p>
         </p:txBody>
@@ -3310,7 +3295,7 @@
               <a:defRPr sz="1600"/>
             </a:pPr>
             <a:r>
-              <a:t>探索分析(EDA)：先看資料分布、缺失與異常，並注意違約屬於少數族群（不平衡）。</a:t>
+              <a:t>資料來源：Kaggle「Home Credit - Credit Risk Model Stability」(2024 年版)——以真實貸款申請人的歷史紀錄，搭配是否違約的結果(target)為標籤，供模型學習。</a:t>
             </a:r>
           </a:p>
           <a:p>
@@ -3318,7 +3303,7 @@
               <a:defRPr sz="1600"/>
             </a:pPr>
             <a:r>
-              <a:t>資料清理：修正異常值與日期格式、處理缺失值，讓資料一致可用。</a:t>
+              <a:t>過往還款行為：逾期天數、準時繳款比例 —— 最直接反映償債意願與能力。</a:t>
             </a:r>
           </a:p>
           <a:p>
@@ -3326,7 +3311,7 @@
               <a:defRPr sz="1600"/>
             </a:pPr>
             <a:r>
-              <a:t>特徵工程：把多筆歷史紀錄彙整成每位申請人的『行為摘要與比率指標』，並挑出最有預測力的特徵。</a:t>
+              <a:t>負債與收入結構：授信金額/收入、月攤還/收入比 —— 衡量還款壓力是否過重。</a:t>
             </a:r>
           </a:p>
           <a:p>
@@ -3334,7 +3319,7 @@
               <a:defRPr sz="1600"/>
             </a:pPr>
             <a:r>
-              <a:t>資料切分(Split)：分訓練/驗證，且依時間切分，確保模型對『未來新案件』仍然準確。</a:t>
+              <a:t>既有信貸狀況：在各機構的貸款筆數與未償餘額 —— 反映整體負債水位。</a:t>
             </a:r>
           </a:p>
           <a:p>
@@ -3342,7 +3327,7 @@
               <a:defRPr sz="1600"/>
             </a:pPr>
             <a:r>
-              <a:t>模型訓練與評估：讓模型從歷史案件學習違約樣態，再用沒看過的資料檢驗可靠度與穩定度。</a:t>
+              <a:t>申請與查詢頻率：短期內多次申請 —— 常是資金緊張的警訊。</a:t>
             </a:r>
           </a:p>
           <a:p>
@@ -3350,7 +3335,15 @@
               <a:defRPr sz="1600"/>
             </a:pPr>
             <a:r>
-              <a:t>產出：為每一筆申請輸出一個『風險分數』。</a:t>
+              <a:t>金流穩定度與申請人輪廓：收入/帳戶進出穩定度、年齡、年資等 —— 反映財務健康並區隔風險族群。</a:t>
+            </a:r>
+          </a:p>
+          <a:p>
+            <a:pPr>
+              <a:defRPr sz="1600"/>
+            </a:pPr>
+            <a:r>
+              <a:t>小結：上述『行為 + 結構』訊號與歷史違約結果高度相關，故模型能據此在統計上區分高/低風險。</a:t>
             </a:r>
           </a:p>
         </p:txBody>
@@ -3389,7 +3382,7 @@
           <a:lstStyle/>
           <a:p>
             <a:r>
-              <a:t>模型產出：風險分數的意義</a:t>
+              <a:t>資料前處理與機器學習流程（總覽）</a:t>
             </a:r>
           </a:p>
         </p:txBody>
@@ -3413,7 +3406,7 @@
               <a:defRPr sz="1600"/>
             </a:pPr>
             <a:r>
-              <a:t>模型把眾多訊號濃縮成單一『風險分數』，便於快速判讀。</a:t>
+              <a:t>探索分析(EDA)：先看資料分布、缺失與異常，並注意違約屬於少數族群（不平衡）。</a:t>
             </a:r>
           </a:p>
           <a:p>
@@ -3421,7 +3414,7 @@
               <a:defRPr sz="1600"/>
             </a:pPr>
             <a:r>
-              <a:t>分數對應違約機率，可切分為 低 / 中 / 高 三個風險等級。</a:t>
+              <a:t>資料清理：修正異常值與日期格式、處理缺失值，讓資料一致可用。</a:t>
             </a:r>
           </a:p>
           <a:p>
@@ -3429,7 +3422,7 @@
               <a:defRPr sz="1600"/>
             </a:pPr>
             <a:r>
-              <a:t>同時列出『主要風險因子』，讓判斷可解釋、可向客戶與主管說明。</a:t>
+              <a:t>特徵工程：把多筆歷史紀錄彙整成每位申請人的『行為摘要與比率指標』，並挑出最有預測力的特徵。</a:t>
             </a:r>
           </a:p>
           <a:p>
@@ -3437,7 +3430,23 @@
               <a:defRPr sz="1600"/>
             </a:pPr>
             <a:r>
-              <a:t>重視穩定度：分數須隨時間維持可靠，不因近期樣態變動而失準。</a:t>
+              <a:t>資料切分(Split)：分訓練/驗證，且依時間切分，確保模型對『未來新案件』仍然準確。</a:t>
+            </a:r>
+          </a:p>
+          <a:p>
+            <a:pPr>
+              <a:defRPr sz="1600"/>
+            </a:pPr>
+            <a:r>
+              <a:t>模型訓練與評估：讓模型從歷史案件學習違約樣態，再用沒看過的資料檢驗可靠度與穩定度。</a:t>
+            </a:r>
+          </a:p>
+          <a:p>
+            <a:pPr>
+              <a:defRPr sz="1600"/>
+            </a:pPr>
+            <a:r>
+              <a:t>產出：為每一筆申請輸出一個『風險分數』。</a:t>
             </a:r>
           </a:p>
         </p:txBody>
@@ -3476,7 +3485,7 @@
           <a:lstStyle/>
           <a:p>
             <a:r>
-              <a:t>實務應用：AI 輔助授信流程</a:t>
+              <a:t>模型產出：風險分數的意義</a:t>
             </a:r>
           </a:p>
         </p:txBody>
@@ -3500,7 +3509,7 @@
               <a:defRPr sz="1600"/>
             </a:pPr>
             <a:r>
-              <a:t>收件 → 帶入/輸入申請人資料 → AI 模型即時產生風險分數與等級。</a:t>
+              <a:t>模型把眾多訊號濃縮成單一『風險分數』，便於快速判讀。</a:t>
             </a:r>
           </a:p>
           <a:p>
@@ -3508,7 +3517,7 @@
               <a:defRPr sz="1600"/>
             </a:pPr>
             <a:r>
-              <a:t>低風險：快速核准；中風險：人工複審並補件；高風險：加強審查或婉拒。</a:t>
+              <a:t>分數對應違約機率，可切分為 低 / 中 / 高 三個風險等級。</a:t>
             </a:r>
           </a:p>
           <a:p>
@@ -3516,7 +3525,7 @@
               <a:defRPr sz="1600"/>
             </a:pPr>
             <a:r>
-              <a:t>AI 是『輔助』而非取代：最終決策由授信人員結合分數、因子與經驗判斷。</a:t>
+              <a:t>同時列出『主要風險因子』，讓判斷可解釋、可向客戶與主管說明。</a:t>
             </a:r>
           </a:p>
           <a:p>
@@ -3524,7 +3533,7 @@
               <a:defRPr sz="1600"/>
             </a:pPr>
             <a:r>
-              <a:t>效益：加速審件、統一風險判讀標準、降低人為遺漏、保留決策軌跡。</a:t>
+              <a:t>重視穩定度：分數須隨時間維持可靠，不因近期樣態變動而失準。</a:t>
             </a:r>
           </a:p>
         </p:txBody>
@@ -3563,7 +3572,7 @@
           <a:lstStyle/>
           <a:p>
             <a:r>
-              <a:t>網頁設計：授信風險評估輔助工具</a:t>
+              <a:t>實務應用：AI 輔助授信流程</a:t>
             </a:r>
           </a:p>
         </p:txBody>
@@ -3587,7 +3596,7 @@
               <a:defRPr sz="1600"/>
             </a:pPr>
             <a:r>
-              <a:t>輸入區：申請人關鍵欄位（年齡、年收入、授信金額、月攤還、年資、過往逾期、既有貸款數、外部信用分數…）。</a:t>
+              <a:t>收件 → 帶入/輸入申請人資料 → AI 模型即時產生風險分數與等級。</a:t>
             </a:r>
           </a:p>
           <a:p>
@@ -3595,7 +3604,7 @@
               <a:defRPr sz="1600"/>
             </a:pPr>
             <a:r>
-              <a:t>一鍵『AI 風險評估』，即時計算。</a:t>
+              <a:t>低風險：快速核准；中風險：人工複審並補件；高風險：加強審查或婉拒。</a:t>
             </a:r>
           </a:p>
           <a:p>
@@ -3603,7 +3612,7 @@
               <a:defRPr sz="1600"/>
             </a:pPr>
             <a:r>
-              <a:t>輸出區：風險分數儀表、風險等級、預估違約機率、主要風險因子清單、建議處置。</a:t>
+              <a:t>AI 是『輔助』而非取代：最終決策由授信人員結合分數、因子與經驗判斷。</a:t>
             </a:r>
           </a:p>
           <a:p>
@@ -3611,15 +3620,7 @@
               <a:defRPr sz="1600"/>
             </a:pPr>
             <a:r>
-              <a:t>合規提示：分數為決策輔助，仍須人工複核並符合法遵要求。</a:t>
-            </a:r>
-          </a:p>
-          <a:p>
-            <a:pPr>
-              <a:defRPr sz="1600"/>
-            </a:pPr>
-            <a:r>
-              <a:t>（實際互動畫面見隨附網頁 credit_risk_app/index.html）</a:t>
+              <a:t>效益：加速審件、統一風險判讀標準、降低人為遺漏、保留決策軌跡。</a:t>
             </a:r>
           </a:p>
         </p:txBody>
@@ -3633,6 +3634,101 @@
 </file>
 
 <file path=ppt/slides/slide7.xml><?xml version="1.0" encoding="utf-8"?>
+<p:sld xmlns:a="http://schemas.openxmlformats.org/drawingml/2006/main" xmlns:p="http://schemas.openxmlformats.org/presentationml/2006/main" xmlns:r="http://schemas.openxmlformats.org/officeDocument/2006/relationships">
+  <p:cSld>
+    <p:spTree>
+      <p:nvGrpSpPr>
+        <p:cNvPr id="1" name=""/>
+        <p:cNvGrpSpPr/>
+        <p:nvPr/>
+      </p:nvGrpSpPr>
+      <p:grpSpPr/>
+      <p:sp>
+        <p:nvSpPr>
+          <p:cNvPr id="2" name="Title 1"/>
+          <p:cNvSpPr>
+            <a:spLocks noGrp="1"/>
+          </p:cNvSpPr>
+          <p:nvPr>
+            <p:ph type="title"/>
+          </p:nvPr>
+        </p:nvSpPr>
+        <p:spPr/>
+        <p:txBody>
+          <a:bodyPr/>
+          <a:lstStyle/>
+          <a:p>
+            <a:r>
+              <a:t>網頁設計：授信風險評估輔助工具</a:t>
+            </a:r>
+          </a:p>
+        </p:txBody>
+      </p:sp>
+      <p:sp>
+        <p:nvSpPr>
+          <p:cNvPr id="3" name="Content Placeholder 2"/>
+          <p:cNvSpPr>
+            <a:spLocks noGrp="1"/>
+          </p:cNvSpPr>
+          <p:nvPr>
+            <p:ph idx="1"/>
+          </p:nvPr>
+        </p:nvSpPr>
+        <p:spPr/>
+        <p:txBody>
+          <a:bodyPr/>
+          <a:lstStyle/>
+          <a:p>
+            <a:pPr>
+              <a:defRPr sz="1600"/>
+            </a:pPr>
+            <a:r>
+              <a:t>輸入區：申請人關鍵欄位（年齡、年收入、授信金額、月攤還、年資、過往逾期、既有貸款數、外部信用分數…）。</a:t>
+            </a:r>
+          </a:p>
+          <a:p>
+            <a:pPr>
+              <a:defRPr sz="1600"/>
+            </a:pPr>
+            <a:r>
+              <a:t>一鍵『AI 風險評估』，即時計算。</a:t>
+            </a:r>
+          </a:p>
+          <a:p>
+            <a:pPr>
+              <a:defRPr sz="1600"/>
+            </a:pPr>
+            <a:r>
+              <a:t>輸出區：風險分數儀表、風險等級、預估違約機率、主要風險因子清單、建議處置。</a:t>
+            </a:r>
+          </a:p>
+          <a:p>
+            <a:pPr>
+              <a:defRPr sz="1600"/>
+            </a:pPr>
+            <a:r>
+              <a:t>合規提示：分數為決策輔助，仍須人工複核並符合法遵要求。</a:t>
+            </a:r>
+          </a:p>
+          <a:p>
+            <a:pPr>
+              <a:defRPr sz="1600"/>
+            </a:pPr>
+            <a:r>
+              <a:t>（實際互動畫面見隨附網頁 credit_risk_app/index.html）</a:t>
+            </a:r>
+          </a:p>
+        </p:txBody>
+      </p:sp>
+    </p:spTree>
+  </p:cSld>
+  <p:clrMapOvr>
+    <a:masterClrMapping/>
+  </p:clrMapOvr>
+</p:sld>
+</file>
+
+<file path=ppt/slides/slide8.xml><?xml version="1.0" encoding="utf-8"?>
 <p:sld xmlns:a="http://schemas.openxmlformats.org/drawingml/2006/main" xmlns:p="http://schemas.openxmlformats.org/presentationml/2006/main" xmlns:r="http://schemas.openxmlformats.org/officeDocument/2006/relationships">
   <p:cSld>
     <p:spTree>

</xml_diff>